<commit_message>
refactor(pptx): fix inefficiencies and improve tests
Fix inefficiencies, bugs, and improve code quality in comment extraction.
Remove poorly-designed tests and add comprehensive, realistic integration tests.
Create more realistic test data with multiple slides, authors, and comment scenarios.

Signed-off-by: Cesar Berrospi Ramis <ceb@zurich.ibm.com>
</commit_message>
<xml_diff>
--- a/tests/data/pptx/powerpoint_comments.pptx
+++ b/tests/data/pptx/powerpoint_comments.pptx
@@ -5,7 +5,9 @@
     <p:sldMasterId id="2147483648" r:id="rId1"/>
   </p:sldMasterIdLst>
   <p:sldIdLst>
-    <p:sldId id="256" r:id="rId7"/>
+    <p:sldId id="256" r:id="rId2"/>
+    <p:sldId id="257" r:id="rId3"/>
+    <p:sldId id="258" r:id="rId4"/>
   </p:sldIdLst>
   <p:sldSz cx="9144000" cy="6858000" type="screen4x3"/>
   <p:notesSz cx="6858000" cy="9144000"/>
@@ -104,20 +106,77 @@
       </a:defRPr>
     </a:lvl9pPr>
   </p:defaultTextStyle>
+  <p:extLst>
+    <p:ext uri="{EFAFB233-063F-42B5-8137-9DF3F51BA10A}">
+      <p15:sldGuideLst xmlns:p15="http://schemas.microsoft.com/office/powerpoint/2012/main">
+        <p15:guide id="1" orient="horz" pos="2160">
+          <p15:clr>
+            <a:srgbClr val="A4A3A4"/>
+          </p15:clr>
+        </p15:guide>
+        <p15:guide id="2" pos="2880">
+          <p15:clr>
+            <a:srgbClr val="A4A3A4"/>
+          </p15:clr>
+        </p15:guide>
+      </p15:sldGuideLst>
+    </p:ext>
+  </p:extLst>
 </p:presentation>
 </file>
 
 <file path=ppt/commentAuthors.xml><?xml version="1.0" encoding="utf-8"?>
-<p:cmAuthorLst xmlns:p="http://schemas.openxmlformats.org/presentationml/2006/main">
-  <p:cmAuthor id="0" name="John Reviewer" initials="JR" lastIdx="1" clrIdx="0"/>
-</p:cmAuthorLst>
+<ns0:cmAuthorLst xmlns:ns0="http://schemas.openxmlformats.org/presentationml/2006/main" xmlns:ns1="http://schemas.microsoft.com/office/powerpoint/2012/main">
+  <ns0:cmAuthor id="0" name="John Reviewer" initials="JR" lastIdx="1" clrIdx="0"/>
+  <ns0:cmAuthor id="1" name="Jane Smith" initials="JS" lastIdx="3" clrIdx="1">
+    <ns0:extLst>
+      <ns0:ext uri="{19B8F6BF-5375-455C-9EA6-DF929625EA0E}">
+        <ns1:presenceInfo userId="S::CEB@zurich.ibm.com::4c5aaf47-e900-4ad4-85d6-a16fad965a8a" providerId="AD"/>
+      </ns0:ext>
+    </ns0:extLst>
+  </ns0:cmAuthor>
+</ns0:cmAuthorLst>
 </file>
 
 <file path=ppt/comments/comment1.xml><?xml version="1.0" encoding="utf-8"?>
-<p:cmLst xmlns:p="http://schemas.openxmlformats.org/presentationml/2006/main">
+<p:cmLst xmlns:a="http://schemas.openxmlformats.org/drawingml/2006/main" xmlns:r="http://schemas.openxmlformats.org/officeDocument/2006/relationships" xmlns:p="http://schemas.openxmlformats.org/presentationml/2006/main">
   <p:cm authorId="0" dt="2026-01-01T00:00:00" idx="1">
     <p:pos x="1000" y="1000"/>
     <p:text>This is a sample reviewer comment</p:text>
+  </p:cm>
+  <p:cm authorId="1" dt="2026-06-18T17:35:35.236" idx="1">
+    <p:pos x="1000" y="1096"/>
+    <p:text>This is a sample response</p:text>
+    <p:extLst>
+      <p:ext uri="{C676402C-5697-4E1C-873F-D02D1690AC5C}">
+        <p15:threadingInfo xmlns:p15="http://schemas.microsoft.com/office/powerpoint/2012/main" timeZoneBias="-120">
+          <p15:parentCm authorId="0" idx="1"/>
+        </p15:threadingInfo>
+      </p:ext>
+    </p:extLst>
+  </p:cm>
+</p:cmLst>
+</file>
+
+<file path=ppt/comments/comment2.xml><?xml version="1.0" encoding="utf-8"?>
+<p:cmLst xmlns:a="http://schemas.openxmlformats.org/drawingml/2006/main" xmlns:r="http://schemas.openxmlformats.org/officeDocument/2006/relationships" xmlns:p="http://schemas.openxmlformats.org/presentationml/2006/main">
+  <p:cm authorId="1" dt="2026-06-18T17:37:55.253" idx="2">
+    <p:pos x="5392" y="1034"/>
+    <p:text>This is a cool feature</p:text>
+    <p:extLst>
+      <p:ext uri="{C676402C-5697-4E1C-873F-D02D1690AC5C}">
+        <p15:threadingInfo xmlns:p15="http://schemas.microsoft.com/office/powerpoint/2012/main" timeZoneBias="-120"/>
+      </p:ext>
+    </p:extLst>
+  </p:cm>
+  <p:cm authorId="1" dt="2026-06-18T17:38:32.720" idx="3">
+    <p:pos x="4823" y="3026"/>
+    <p:text>I need to try this out!</p:text>
+    <p:extLst>
+      <p:ext uri="{C676402C-5697-4E1C-873F-D02D1690AC5C}">
+        <p15:threadingInfo xmlns:p15="http://schemas.microsoft.com/office/powerpoint/2012/main" timeZoneBias="-120"/>
+      </p:ext>
+    </p:extLst>
   </p:cm>
 </p:cmLst>
 </file>
@@ -160,10 +219,9 @@
           <a:lstStyle/>
           <a:p>
             <a:r>
-              <a:rPr lang="en-US" smtClean="0"/>
+              <a:rPr lang="en-US"/>
               <a:t>Click to edit Master title style</a:t>
             </a:r>
-            <a:endParaRPr lang="en-US"/>
           </a:p>
         </p:txBody>
       </p:sp>
@@ -279,10 +337,9 @@
           </a:lstStyle>
           <a:p>
             <a:r>
-              <a:rPr lang="en-US" smtClean="0"/>
+              <a:rPr lang="en-US"/>
               <a:t>Click to edit Master subtitle style</a:t>
             </a:r>
-            <a:endParaRPr lang="en-US"/>
           </a:p>
         </p:txBody>
       </p:sp>
@@ -303,7 +360,7 @@
           <a:p>
             <a:fld id="{5BCAD085-E8A6-8845-BD4E-CB4CCA059FC4}" type="datetimeFigureOut">
               <a:rPr lang="en-US" smtClean="0"/>
-              <a:t>1/27/13</a:t>
+              <a:t>6/18/26</a:t>
             </a:fld>
             <a:endParaRPr lang="en-US"/>
           </a:p>
@@ -397,10 +454,9 @@
           <a:lstStyle/>
           <a:p>
             <a:r>
-              <a:rPr lang="en-US" smtClean="0"/>
+              <a:rPr lang="en-US"/>
               <a:t>Click to edit Master title style</a:t>
             </a:r>
-            <a:endParaRPr lang="en-US"/>
           </a:p>
         </p:txBody>
       </p:sp>
@@ -421,38 +477,37 @@
           <a:p>
             <a:pPr lvl="0"/>
             <a:r>
-              <a:rPr lang="en-US" smtClean="0"/>
+              <a:rPr lang="en-US"/>
               <a:t>Click to edit Master text styles</a:t>
             </a:r>
           </a:p>
           <a:p>
             <a:pPr lvl="1"/>
             <a:r>
-              <a:rPr lang="en-US" smtClean="0"/>
+              <a:rPr lang="en-US"/>
               <a:t>Second level</a:t>
             </a:r>
           </a:p>
           <a:p>
             <a:pPr lvl="2"/>
             <a:r>
-              <a:rPr lang="en-US" smtClean="0"/>
+              <a:rPr lang="en-US"/>
               <a:t>Third level</a:t>
             </a:r>
           </a:p>
           <a:p>
             <a:pPr lvl="3"/>
             <a:r>
-              <a:rPr lang="en-US" smtClean="0"/>
+              <a:rPr lang="en-US"/>
               <a:t>Fourth level</a:t>
             </a:r>
           </a:p>
           <a:p>
             <a:pPr lvl="4"/>
             <a:r>
-              <a:rPr lang="en-US" smtClean="0"/>
+              <a:rPr lang="en-US"/>
               <a:t>Fifth level</a:t>
             </a:r>
-            <a:endParaRPr lang="en-US"/>
           </a:p>
         </p:txBody>
       </p:sp>
@@ -473,7 +528,7 @@
           <a:p>
             <a:fld id="{5BCAD085-E8A6-8845-BD4E-CB4CCA059FC4}" type="datetimeFigureOut">
               <a:rPr lang="en-US" smtClean="0"/>
-              <a:t>1/27/13</a:t>
+              <a:t>6/18/26</a:t>
             </a:fld>
             <a:endParaRPr lang="en-US"/>
           </a:p>
@@ -572,10 +627,9 @@
           <a:lstStyle/>
           <a:p>
             <a:r>
-              <a:rPr lang="en-US" smtClean="0"/>
+              <a:rPr lang="en-US"/>
               <a:t>Click to edit Master title style</a:t>
             </a:r>
-            <a:endParaRPr lang="en-US"/>
           </a:p>
         </p:txBody>
       </p:sp>
@@ -601,38 +655,37 @@
           <a:p>
             <a:pPr lvl="0"/>
             <a:r>
-              <a:rPr lang="en-US" smtClean="0"/>
+              <a:rPr lang="en-US"/>
               <a:t>Click to edit Master text styles</a:t>
             </a:r>
           </a:p>
           <a:p>
             <a:pPr lvl="1"/>
             <a:r>
-              <a:rPr lang="en-US" smtClean="0"/>
+              <a:rPr lang="en-US"/>
               <a:t>Second level</a:t>
             </a:r>
           </a:p>
           <a:p>
             <a:pPr lvl="2"/>
             <a:r>
-              <a:rPr lang="en-US" smtClean="0"/>
+              <a:rPr lang="en-US"/>
               <a:t>Third level</a:t>
             </a:r>
           </a:p>
           <a:p>
             <a:pPr lvl="3"/>
             <a:r>
-              <a:rPr lang="en-US" smtClean="0"/>
+              <a:rPr lang="en-US"/>
               <a:t>Fourth level</a:t>
             </a:r>
           </a:p>
           <a:p>
             <a:pPr lvl="4"/>
             <a:r>
-              <a:rPr lang="en-US" smtClean="0"/>
+              <a:rPr lang="en-US"/>
               <a:t>Fifth level</a:t>
             </a:r>
-            <a:endParaRPr lang="en-US"/>
           </a:p>
         </p:txBody>
       </p:sp>
@@ -653,7 +706,7 @@
           <a:p>
             <a:fld id="{5BCAD085-E8A6-8845-BD4E-CB4CCA059FC4}" type="datetimeFigureOut">
               <a:rPr lang="en-US" smtClean="0"/>
-              <a:t>1/27/13</a:t>
+              <a:t>6/18/26</a:t>
             </a:fld>
             <a:endParaRPr lang="en-US"/>
           </a:p>
@@ -747,10 +800,9 @@
           <a:lstStyle/>
           <a:p>
             <a:r>
-              <a:rPr lang="en-US" smtClean="0"/>
+              <a:rPr lang="en-US"/>
               <a:t>Click to edit Master title style</a:t>
             </a:r>
-            <a:endParaRPr lang="en-US"/>
           </a:p>
         </p:txBody>
       </p:sp>
@@ -771,38 +823,37 @@
           <a:p>
             <a:pPr lvl="0"/>
             <a:r>
-              <a:rPr lang="en-US" smtClean="0"/>
+              <a:rPr lang="en-US"/>
               <a:t>Click to edit Master text styles</a:t>
             </a:r>
           </a:p>
           <a:p>
             <a:pPr lvl="1"/>
             <a:r>
-              <a:rPr lang="en-US" smtClean="0"/>
+              <a:rPr lang="en-US"/>
               <a:t>Second level</a:t>
             </a:r>
           </a:p>
           <a:p>
             <a:pPr lvl="2"/>
             <a:r>
-              <a:rPr lang="en-US" smtClean="0"/>
+              <a:rPr lang="en-US"/>
               <a:t>Third level</a:t>
             </a:r>
           </a:p>
           <a:p>
             <a:pPr lvl="3"/>
             <a:r>
-              <a:rPr lang="en-US" smtClean="0"/>
+              <a:rPr lang="en-US"/>
               <a:t>Fourth level</a:t>
             </a:r>
           </a:p>
           <a:p>
             <a:pPr lvl="4"/>
             <a:r>
-              <a:rPr lang="en-US" smtClean="0"/>
+              <a:rPr lang="en-US"/>
               <a:t>Fifth level</a:t>
             </a:r>
-            <a:endParaRPr lang="en-US"/>
           </a:p>
         </p:txBody>
       </p:sp>
@@ -823,7 +874,7 @@
           <a:p>
             <a:fld id="{5BCAD085-E8A6-8845-BD4E-CB4CCA059FC4}" type="datetimeFigureOut">
               <a:rPr lang="en-US" smtClean="0"/>
-              <a:t>1/27/13</a:t>
+              <a:t>6/18/26</a:t>
             </a:fld>
             <a:endParaRPr lang="en-US"/>
           </a:p>
@@ -926,10 +977,9 @@
           </a:lstStyle>
           <a:p>
             <a:r>
-              <a:rPr lang="en-US" smtClean="0"/>
+              <a:rPr lang="en-US"/>
               <a:t>Click to edit Master title style</a:t>
             </a:r>
-            <a:endParaRPr lang="en-US"/>
           </a:p>
         </p:txBody>
       </p:sp>
@@ -1046,7 +1096,7 @@
           <a:p>
             <a:pPr lvl="0"/>
             <a:r>
-              <a:rPr lang="en-US" smtClean="0"/>
+              <a:rPr lang="en-US"/>
               <a:t>Click to edit Master text styles</a:t>
             </a:r>
           </a:p>
@@ -1069,7 +1119,7 @@
           <a:p>
             <a:fld id="{5BCAD085-E8A6-8845-BD4E-CB4CCA059FC4}" type="datetimeFigureOut">
               <a:rPr lang="en-US" smtClean="0"/>
-              <a:t>1/27/13</a:t>
+              <a:t>6/18/26</a:t>
             </a:fld>
             <a:endParaRPr lang="en-US"/>
           </a:p>
@@ -1163,10 +1213,9 @@
           <a:lstStyle/>
           <a:p>
             <a:r>
-              <a:rPr lang="en-US" smtClean="0"/>
+              <a:rPr lang="en-US"/>
               <a:t>Click to edit Master title style</a:t>
             </a:r>
-            <a:endParaRPr lang="en-US"/>
           </a:p>
         </p:txBody>
       </p:sp>
@@ -1220,38 +1269,37 @@
           <a:p>
             <a:pPr lvl="0"/>
             <a:r>
-              <a:rPr lang="en-US" smtClean="0"/>
+              <a:rPr lang="en-US"/>
               <a:t>Click to edit Master text styles</a:t>
             </a:r>
           </a:p>
           <a:p>
             <a:pPr lvl="1"/>
             <a:r>
-              <a:rPr lang="en-US" smtClean="0"/>
+              <a:rPr lang="en-US"/>
               <a:t>Second level</a:t>
             </a:r>
           </a:p>
           <a:p>
             <a:pPr lvl="2"/>
             <a:r>
-              <a:rPr lang="en-US" smtClean="0"/>
+              <a:rPr lang="en-US"/>
               <a:t>Third level</a:t>
             </a:r>
           </a:p>
           <a:p>
             <a:pPr lvl="3"/>
             <a:r>
-              <a:rPr lang="en-US" smtClean="0"/>
+              <a:rPr lang="en-US"/>
               <a:t>Fourth level</a:t>
             </a:r>
           </a:p>
           <a:p>
             <a:pPr lvl="4"/>
             <a:r>
-              <a:rPr lang="en-US" smtClean="0"/>
+              <a:rPr lang="en-US"/>
               <a:t>Fifth level</a:t>
             </a:r>
-            <a:endParaRPr lang="en-US"/>
           </a:p>
         </p:txBody>
       </p:sp>
@@ -1305,38 +1353,37 @@
           <a:p>
             <a:pPr lvl="0"/>
             <a:r>
-              <a:rPr lang="en-US" smtClean="0"/>
+              <a:rPr lang="en-US"/>
               <a:t>Click to edit Master text styles</a:t>
             </a:r>
           </a:p>
           <a:p>
             <a:pPr lvl="1"/>
             <a:r>
-              <a:rPr lang="en-US" smtClean="0"/>
+              <a:rPr lang="en-US"/>
               <a:t>Second level</a:t>
             </a:r>
           </a:p>
           <a:p>
             <a:pPr lvl="2"/>
             <a:r>
-              <a:rPr lang="en-US" smtClean="0"/>
+              <a:rPr lang="en-US"/>
               <a:t>Third level</a:t>
             </a:r>
           </a:p>
           <a:p>
             <a:pPr lvl="3"/>
             <a:r>
-              <a:rPr lang="en-US" smtClean="0"/>
+              <a:rPr lang="en-US"/>
               <a:t>Fourth level</a:t>
             </a:r>
           </a:p>
           <a:p>
             <a:pPr lvl="4"/>
             <a:r>
-              <a:rPr lang="en-US" smtClean="0"/>
+              <a:rPr lang="en-US"/>
               <a:t>Fifth level</a:t>
             </a:r>
-            <a:endParaRPr lang="en-US"/>
           </a:p>
         </p:txBody>
       </p:sp>
@@ -1357,7 +1404,7 @@
           <a:p>
             <a:fld id="{5BCAD085-E8A6-8845-BD4E-CB4CCA059FC4}" type="datetimeFigureOut">
               <a:rPr lang="en-US" smtClean="0"/>
-              <a:t>1/27/13</a:t>
+              <a:t>6/18/26</a:t>
             </a:fld>
             <a:endParaRPr lang="en-US"/>
           </a:p>
@@ -1455,10 +1502,9 @@
           </a:lstStyle>
           <a:p>
             <a:r>
-              <a:rPr lang="en-US" smtClean="0"/>
+              <a:rPr lang="en-US"/>
               <a:t>Click to edit Master title style</a:t>
             </a:r>
-            <a:endParaRPr lang="en-US"/>
           </a:p>
         </p:txBody>
       </p:sp>
@@ -1521,7 +1567,7 @@
           <a:p>
             <a:pPr lvl="0"/>
             <a:r>
-              <a:rPr lang="en-US" smtClean="0"/>
+              <a:rPr lang="en-US"/>
               <a:t>Click to edit Master text styles</a:t>
             </a:r>
           </a:p>
@@ -1577,38 +1623,37 @@
           <a:p>
             <a:pPr lvl="0"/>
             <a:r>
-              <a:rPr lang="en-US" smtClean="0"/>
+              <a:rPr lang="en-US"/>
               <a:t>Click to edit Master text styles</a:t>
             </a:r>
           </a:p>
           <a:p>
             <a:pPr lvl="1"/>
             <a:r>
-              <a:rPr lang="en-US" smtClean="0"/>
+              <a:rPr lang="en-US"/>
               <a:t>Second level</a:t>
             </a:r>
           </a:p>
           <a:p>
             <a:pPr lvl="2"/>
             <a:r>
-              <a:rPr lang="en-US" smtClean="0"/>
+              <a:rPr lang="en-US"/>
               <a:t>Third level</a:t>
             </a:r>
           </a:p>
           <a:p>
             <a:pPr lvl="3"/>
             <a:r>
-              <a:rPr lang="en-US" smtClean="0"/>
+              <a:rPr lang="en-US"/>
               <a:t>Fourth level</a:t>
             </a:r>
           </a:p>
           <a:p>
             <a:pPr lvl="4"/>
             <a:r>
-              <a:rPr lang="en-US" smtClean="0"/>
+              <a:rPr lang="en-US"/>
               <a:t>Fifth level</a:t>
             </a:r>
-            <a:endParaRPr lang="en-US"/>
           </a:p>
         </p:txBody>
       </p:sp>
@@ -1671,7 +1716,7 @@
           <a:p>
             <a:pPr lvl="0"/>
             <a:r>
-              <a:rPr lang="en-US" smtClean="0"/>
+              <a:rPr lang="en-US"/>
               <a:t>Click to edit Master text styles</a:t>
             </a:r>
           </a:p>
@@ -1727,38 +1772,37 @@
           <a:p>
             <a:pPr lvl="0"/>
             <a:r>
-              <a:rPr lang="en-US" smtClean="0"/>
+              <a:rPr lang="en-US"/>
               <a:t>Click to edit Master text styles</a:t>
             </a:r>
           </a:p>
           <a:p>
             <a:pPr lvl="1"/>
             <a:r>
-              <a:rPr lang="en-US" smtClean="0"/>
+              <a:rPr lang="en-US"/>
               <a:t>Second level</a:t>
             </a:r>
           </a:p>
           <a:p>
             <a:pPr lvl="2"/>
             <a:r>
-              <a:rPr lang="en-US" smtClean="0"/>
+              <a:rPr lang="en-US"/>
               <a:t>Third level</a:t>
             </a:r>
           </a:p>
           <a:p>
             <a:pPr lvl="3"/>
             <a:r>
-              <a:rPr lang="en-US" smtClean="0"/>
+              <a:rPr lang="en-US"/>
               <a:t>Fourth level</a:t>
             </a:r>
           </a:p>
           <a:p>
             <a:pPr lvl="4"/>
             <a:r>
-              <a:rPr lang="en-US" smtClean="0"/>
+              <a:rPr lang="en-US"/>
               <a:t>Fifth level</a:t>
             </a:r>
-            <a:endParaRPr lang="en-US"/>
           </a:p>
         </p:txBody>
       </p:sp>
@@ -1779,7 +1823,7 @@
           <a:p>
             <a:fld id="{5BCAD085-E8A6-8845-BD4E-CB4CCA059FC4}" type="datetimeFigureOut">
               <a:rPr lang="en-US" smtClean="0"/>
-              <a:t>1/27/13</a:t>
+              <a:t>6/18/26</a:t>
             </a:fld>
             <a:endParaRPr lang="en-US"/>
           </a:p>
@@ -1873,10 +1917,9 @@
           <a:lstStyle/>
           <a:p>
             <a:r>
-              <a:rPr lang="en-US" smtClean="0"/>
+              <a:rPr lang="en-US"/>
               <a:t>Click to edit Master title style</a:t>
             </a:r>
-            <a:endParaRPr lang="en-US"/>
           </a:p>
         </p:txBody>
       </p:sp>
@@ -1897,7 +1940,7 @@
           <a:p>
             <a:fld id="{5BCAD085-E8A6-8845-BD4E-CB4CCA059FC4}" type="datetimeFigureOut">
               <a:rPr lang="en-US" smtClean="0"/>
-              <a:t>1/27/13</a:t>
+              <a:t>6/18/26</a:t>
             </a:fld>
             <a:endParaRPr lang="en-US"/>
           </a:p>
@@ -1992,7 +2035,7 @@
           <a:p>
             <a:fld id="{5BCAD085-E8A6-8845-BD4E-CB4CCA059FC4}" type="datetimeFigureOut">
               <a:rPr lang="en-US" smtClean="0"/>
-              <a:t>1/27/13</a:t>
+              <a:t>6/18/26</a:t>
             </a:fld>
             <a:endParaRPr lang="en-US"/>
           </a:p>
@@ -2095,10 +2138,9 @@
           </a:lstStyle>
           <a:p>
             <a:r>
-              <a:rPr lang="en-US" smtClean="0"/>
+              <a:rPr lang="en-US"/>
               <a:t>Click to edit Master title style</a:t>
             </a:r>
-            <a:endParaRPr lang="en-US"/>
           </a:p>
         </p:txBody>
       </p:sp>
@@ -2152,38 +2194,37 @@
           <a:p>
             <a:pPr lvl="0"/>
             <a:r>
-              <a:rPr lang="en-US" smtClean="0"/>
+              <a:rPr lang="en-US"/>
               <a:t>Click to edit Master text styles</a:t>
             </a:r>
           </a:p>
           <a:p>
             <a:pPr lvl="1"/>
             <a:r>
-              <a:rPr lang="en-US" smtClean="0"/>
+              <a:rPr lang="en-US"/>
               <a:t>Second level</a:t>
             </a:r>
           </a:p>
           <a:p>
             <a:pPr lvl="2"/>
             <a:r>
-              <a:rPr lang="en-US" smtClean="0"/>
+              <a:rPr lang="en-US"/>
               <a:t>Third level</a:t>
             </a:r>
           </a:p>
           <a:p>
             <a:pPr lvl="3"/>
             <a:r>
-              <a:rPr lang="en-US" smtClean="0"/>
+              <a:rPr lang="en-US"/>
               <a:t>Fourth level</a:t>
             </a:r>
           </a:p>
           <a:p>
             <a:pPr lvl="4"/>
             <a:r>
-              <a:rPr lang="en-US" smtClean="0"/>
+              <a:rPr lang="en-US"/>
               <a:t>Fifth level</a:t>
             </a:r>
-            <a:endParaRPr lang="en-US"/>
           </a:p>
         </p:txBody>
       </p:sp>
@@ -2246,7 +2287,7 @@
           <a:p>
             <a:pPr lvl="0"/>
             <a:r>
-              <a:rPr lang="en-US" smtClean="0"/>
+              <a:rPr lang="en-US"/>
               <a:t>Click to edit Master text styles</a:t>
             </a:r>
           </a:p>
@@ -2269,7 +2310,7 @@
           <a:p>
             <a:fld id="{5BCAD085-E8A6-8845-BD4E-CB4CCA059FC4}" type="datetimeFigureOut">
               <a:rPr lang="en-US" smtClean="0"/>
-              <a:t>1/27/13</a:t>
+              <a:t>6/18/26</a:t>
             </a:fld>
             <a:endParaRPr lang="en-US"/>
           </a:p>
@@ -2372,10 +2413,9 @@
           </a:lstStyle>
           <a:p>
             <a:r>
-              <a:rPr lang="en-US" smtClean="0"/>
+              <a:rPr lang="en-US"/>
               <a:t>Click to edit Master title style</a:t>
             </a:r>
-            <a:endParaRPr lang="en-US"/>
           </a:p>
         </p:txBody>
       </p:sp>
@@ -2499,7 +2539,7 @@
           <a:p>
             <a:pPr lvl="0"/>
             <a:r>
-              <a:rPr lang="en-US" smtClean="0"/>
+              <a:rPr lang="en-US"/>
               <a:t>Click to edit Master text styles</a:t>
             </a:r>
           </a:p>
@@ -2522,7 +2562,7 @@
           <a:p>
             <a:fld id="{5BCAD085-E8A6-8845-BD4E-CB4CCA059FC4}" type="datetimeFigureOut">
               <a:rPr lang="en-US" smtClean="0"/>
-              <a:t>1/27/13</a:t>
+              <a:t>6/18/26</a:t>
             </a:fld>
             <a:endParaRPr lang="en-US"/>
           </a:p>
@@ -2631,10 +2671,9 @@
           <a:lstStyle/>
           <a:p>
             <a:r>
-              <a:rPr lang="en-US" smtClean="0"/>
+              <a:rPr lang="en-US"/>
               <a:t>Click to edit Master title style</a:t>
             </a:r>
-            <a:endParaRPr lang="en-US"/>
           </a:p>
         </p:txBody>
       </p:sp>
@@ -2665,38 +2704,37 @@
           <a:p>
             <a:pPr lvl="0"/>
             <a:r>
-              <a:rPr lang="en-US" smtClean="0"/>
+              <a:rPr lang="en-US"/>
               <a:t>Click to edit Master text styles</a:t>
             </a:r>
           </a:p>
           <a:p>
             <a:pPr lvl="1"/>
             <a:r>
-              <a:rPr lang="en-US" smtClean="0"/>
+              <a:rPr lang="en-US"/>
               <a:t>Second level</a:t>
             </a:r>
           </a:p>
           <a:p>
             <a:pPr lvl="2"/>
             <a:r>
-              <a:rPr lang="en-US" smtClean="0"/>
+              <a:rPr lang="en-US"/>
               <a:t>Third level</a:t>
             </a:r>
           </a:p>
           <a:p>
             <a:pPr lvl="3"/>
             <a:r>
-              <a:rPr lang="en-US" smtClean="0"/>
+              <a:rPr lang="en-US"/>
               <a:t>Fourth level</a:t>
             </a:r>
           </a:p>
           <a:p>
             <a:pPr lvl="4"/>
             <a:r>
-              <a:rPr lang="en-US" smtClean="0"/>
+              <a:rPr lang="en-US"/>
               <a:t>Fifth level</a:t>
             </a:r>
-            <a:endParaRPr lang="en-US"/>
           </a:p>
         </p:txBody>
       </p:sp>
@@ -2735,7 +2773,7 @@
           <a:p>
             <a:fld id="{5BCAD085-E8A6-8845-BD4E-CB4CCA059FC4}" type="datetimeFigureOut">
               <a:rPr lang="en-US" smtClean="0"/>
-              <a:t>1/27/13</a:t>
+              <a:t>6/18/26</a:t>
             </a:fld>
             <a:endParaRPr lang="en-US"/>
           </a:p>
@@ -3094,7 +3132,7 @@
 </file>
 
 <file path=ppt/slides/slide1.xml><?xml version="1.0" encoding="utf-8"?>
-<p:sld xmlns:a="http://schemas.openxmlformats.org/drawingml/2006/main" xmlns:p="http://schemas.openxmlformats.org/presentationml/2006/main" xmlns:r="http://schemas.openxmlformats.org/officeDocument/2006/relationships">
+<p:sld xmlns:a="http://schemas.openxmlformats.org/drawingml/2006/main" xmlns:r="http://schemas.openxmlformats.org/officeDocument/2006/relationships" xmlns:p="http://schemas.openxmlformats.org/presentationml/2006/main">
   <p:cSld>
     <p:spTree>
       <p:nvGrpSpPr>
@@ -3102,7 +3140,14 @@
         <p:cNvGrpSpPr/>
         <p:nvPr/>
       </p:nvGrpSpPr>
-      <p:grpSpPr/>
+      <p:grpSpPr>
+        <a:xfrm>
+          <a:off x="0" y="0"/>
+          <a:ext cx="0" cy="0"/>
+          <a:chOff x="0" y="0"/>
+          <a:chExt cx="0" cy="0"/>
+        </a:xfrm>
+      </p:grpSpPr>
       <p:sp>
         <p:nvSpPr>
           <p:cNvPr id="2" name="Title 1"/>
@@ -3119,6 +3164,7 @@
           <a:lstStyle/>
           <a:p>
             <a:r>
+              <a:rPr dirty="0"/>
               <a:t>Test Slide With Comments</a:t>
             </a:r>
           </a:p>
@@ -3138,10 +3184,249 @@
         <p:txBody>
           <a:bodyPr/>
           <a:lstStyle/>
-          <a:p/>
+          <a:p>
+            <a:pPr marL="0" indent="0">
+              <a:buNone/>
+            </a:pPr>
+            <a:r>
+              <a:rPr lang="en-US" dirty="0" err="1"/>
+              <a:t>Docling</a:t>
+            </a:r>
+            <a:r>
+              <a:rPr lang="en-US" dirty="0"/>
+              <a:t> converts messy documents into structured data and simplifies downstream document and AI processing by detecting tables, formulas, reading order, OCR, and much more.</a:t>
+            </a:r>
+          </a:p>
         </p:txBody>
       </p:sp>
     </p:spTree>
+  </p:cSld>
+  <p:clrMapOvr>
+    <a:masterClrMapping/>
+  </p:clrMapOvr>
+</p:sld>
+</file>
+
+<file path=ppt/slides/slide2.xml><?xml version="1.0" encoding="utf-8"?>
+<p:sld xmlns:a="http://schemas.openxmlformats.org/drawingml/2006/main" xmlns:r="http://schemas.openxmlformats.org/officeDocument/2006/relationships" xmlns:p="http://schemas.openxmlformats.org/presentationml/2006/main">
+  <p:cSld>
+    <p:spTree>
+      <p:nvGrpSpPr>
+        <p:cNvPr id="1" name=""/>
+        <p:cNvGrpSpPr/>
+        <p:nvPr/>
+      </p:nvGrpSpPr>
+      <p:grpSpPr>
+        <a:xfrm>
+          <a:off x="0" y="0"/>
+          <a:ext cx="0" cy="0"/>
+          <a:chOff x="0" y="0"/>
+          <a:chExt cx="0" cy="0"/>
+        </a:xfrm>
+      </p:grpSpPr>
+      <p:sp>
+        <p:nvSpPr>
+          <p:cNvPr id="2" name="Title 1">
+            <a:extLst>
+              <a:ext uri="{FF2B5EF4-FFF2-40B4-BE49-F238E27FC236}">
+                <a16:creationId xmlns:a16="http://schemas.microsoft.com/office/drawing/2014/main" id="{7BB4EF4B-AD7F-F39F-817E-D86CB4882DE6}"/>
+              </a:ext>
+            </a:extLst>
+          </p:cNvPr>
+          <p:cNvSpPr>
+            <a:spLocks noGrp="1"/>
+          </p:cNvSpPr>
+          <p:nvPr>
+            <p:ph type="title"/>
+          </p:nvPr>
+        </p:nvSpPr>
+        <p:spPr/>
+        <p:txBody>
+          <a:bodyPr>
+            <a:normAutofit/>
+          </a:bodyPr>
+          <a:lstStyle/>
+          <a:p>
+            <a:r>
+              <a:rPr lang="en-US" dirty="0"/>
+              <a:t>Start</a:t>
+            </a:r>
+          </a:p>
+        </p:txBody>
+      </p:sp>
+      <p:sp>
+        <p:nvSpPr>
+          <p:cNvPr id="3" name="Content Placeholder 2">
+            <a:extLst>
+              <a:ext uri="{FF2B5EF4-FFF2-40B4-BE49-F238E27FC236}">
+                <a16:creationId xmlns:a16="http://schemas.microsoft.com/office/drawing/2014/main" id="{B3602232-BC28-7241-2107-91C0E17D76F2}"/>
+              </a:ext>
+            </a:extLst>
+          </p:cNvPr>
+          <p:cNvSpPr>
+            <a:spLocks noGrp="1"/>
+          </p:cNvSpPr>
+          <p:nvPr>
+            <p:ph idx="1"/>
+          </p:nvPr>
+        </p:nvSpPr>
+        <p:spPr/>
+        <p:txBody>
+          <a:bodyPr/>
+          <a:lstStyle/>
+          <a:p>
+            <a:pPr marL="0" indent="0">
+              <a:buNone/>
+            </a:pPr>
+            <a:r>
+              <a:rPr lang="en-US" dirty="0"/>
+              <a:t>Install </a:t>
+            </a:r>
+            <a:r>
+              <a:rPr lang="en-US" dirty="0" err="1"/>
+              <a:t>Docling</a:t>
+            </a:r>
+            <a:r>
+              <a:rPr lang="en-US" dirty="0"/>
+              <a:t> as a </a:t>
+            </a:r>
+            <a:r>
+              <a:rPr lang="en-US" dirty="0">
+                <a:hlinkClick r:id="rId2"/>
+              </a:rPr>
+              <a:t>Python library</a:t>
+            </a:r>
+            <a:r>
+              <a:rPr lang="en-US" dirty="0"/>
+              <a:t> with your favorite package manager</a:t>
+            </a:r>
+          </a:p>
+        </p:txBody>
+      </p:sp>
+    </p:spTree>
+    <p:extLst>
+      <p:ext uri="{BB962C8B-B14F-4D97-AF65-F5344CB8AC3E}">
+        <p14:creationId xmlns:p14="http://schemas.microsoft.com/office/powerpoint/2010/main" val="2320508542"/>
+      </p:ext>
+    </p:extLst>
+  </p:cSld>
+  <p:clrMapOvr>
+    <a:masterClrMapping/>
+  </p:clrMapOvr>
+</p:sld>
+</file>
+
+<file path=ppt/slides/slide3.xml><?xml version="1.0" encoding="utf-8"?>
+<p:sld xmlns:a="http://schemas.openxmlformats.org/drawingml/2006/main" xmlns:r="http://schemas.openxmlformats.org/officeDocument/2006/relationships" xmlns:p="http://schemas.openxmlformats.org/presentationml/2006/main">
+  <p:cSld>
+    <p:spTree>
+      <p:nvGrpSpPr>
+        <p:cNvPr id="1" name=""/>
+        <p:cNvGrpSpPr/>
+        <p:nvPr/>
+      </p:nvGrpSpPr>
+      <p:grpSpPr>
+        <a:xfrm>
+          <a:off x="0" y="0"/>
+          <a:ext cx="0" cy="0"/>
+          <a:chOff x="0" y="0"/>
+          <a:chExt cx="0" cy="0"/>
+        </a:xfrm>
+      </p:grpSpPr>
+      <p:sp>
+        <p:nvSpPr>
+          <p:cNvPr id="2" name="Title 1">
+            <a:extLst>
+              <a:ext uri="{FF2B5EF4-FFF2-40B4-BE49-F238E27FC236}">
+                <a16:creationId xmlns:a16="http://schemas.microsoft.com/office/drawing/2014/main" id="{8F4056AE-94C3-F1D9-5D5A-52B8226F390B}"/>
+              </a:ext>
+            </a:extLst>
+          </p:cNvPr>
+          <p:cNvSpPr>
+            <a:spLocks noGrp="1"/>
+          </p:cNvSpPr>
+          <p:nvPr>
+            <p:ph type="title"/>
+          </p:nvPr>
+        </p:nvSpPr>
+        <p:spPr/>
+        <p:txBody>
+          <a:bodyPr>
+            <a:normAutofit/>
+          </a:bodyPr>
+          <a:lstStyle/>
+          <a:p>
+            <a:r>
+              <a:rPr lang="en-US" dirty="0"/>
+              <a:t>Features</a:t>
+            </a:r>
+          </a:p>
+        </p:txBody>
+      </p:sp>
+      <p:sp>
+        <p:nvSpPr>
+          <p:cNvPr id="3" name="Content Placeholder 2">
+            <a:extLst>
+              <a:ext uri="{FF2B5EF4-FFF2-40B4-BE49-F238E27FC236}">
+                <a16:creationId xmlns:a16="http://schemas.microsoft.com/office/drawing/2014/main" id="{6C80BDD3-65FB-939B-4A97-252A7F78A295}"/>
+              </a:ext>
+            </a:extLst>
+          </p:cNvPr>
+          <p:cNvSpPr>
+            <a:spLocks noGrp="1"/>
+          </p:cNvSpPr>
+          <p:nvPr>
+            <p:ph idx="1"/>
+          </p:nvPr>
+        </p:nvSpPr>
+        <p:spPr/>
+        <p:txBody>
+          <a:bodyPr>
+            <a:normAutofit lnSpcReduction="10000"/>
+          </a:bodyPr>
+          <a:lstStyle/>
+          <a:p>
+            <a:r>
+              <a:rPr lang="en-US" dirty="0"/>
+              <a:t>Import many document formats into a unified and structured </a:t>
+            </a:r>
+            <a:r>
+              <a:rPr lang="en-US" dirty="0" err="1"/>
+              <a:t>Docling</a:t>
+            </a:r>
+            <a:r>
+              <a:rPr lang="en-US" dirty="0"/>
+              <a:t> Document , including scanned pages via an OCR engine of your choice.</a:t>
+            </a:r>
+          </a:p>
+          <a:p>
+            <a:r>
+              <a:rPr lang="en-US" dirty="0"/>
+              <a:t>Export a parsed document to formats that simplify processing and ingestion into AI, RAG, and agentic systems. </a:t>
+            </a:r>
+          </a:p>
+          <a:p>
+            <a:r>
+              <a:rPr lang="en-US" dirty="0"/>
+              <a:t>Extract document components and their properties from the </a:t>
+            </a:r>
+            <a:r>
+              <a:rPr lang="en-US" dirty="0" err="1"/>
+              <a:t>Docling</a:t>
+            </a:r>
+            <a:r>
+              <a:rPr lang="en-US" dirty="0"/>
+              <a:t> Document.</a:t>
+            </a:r>
+          </a:p>
+        </p:txBody>
+      </p:sp>
+    </p:spTree>
+    <p:extLst>
+      <p:ext uri="{BB962C8B-B14F-4D97-AF65-F5344CB8AC3E}">
+        <p14:creationId xmlns:p14="http://schemas.microsoft.com/office/powerpoint/2010/main" val="2807389121"/>
+      </p:ext>
+    </p:extLst>
   </p:cSld>
   <p:clrMapOvr>
     <a:masterClrMapping/>

</xml_diff>